<commit_message>
Pitch: telas recortadas, contraste, vírgula decimal e frase fiel aos números
Co-Authored-By: Claude Opus 5 <noreply@anthropic.com>
</commit_message>
<xml_diff>
--- a/Projeto_Final_Artefatos/InsurMinds_Projeto_Final.pptx
+++ b/Projeto_Final_Artefatos/InsurMinds_Projeto_Final.pptx
@@ -3951,11 +3951,11 @@
           <a:p>
             <a:pPr algn="ctr">
               <a:spcAft>
-                <a:spcPts val="1530"/>
-              </a:spcAft>
-            </a:pPr>
-            <a:r>
-              <a:rPr sz="3400" b="1">
+                <a:spcPts val="1170"/>
+              </a:spcAft>
+            </a:pPr>
+            <a:r>
+              <a:rPr sz="2600" b="1">
                 <a:solidFill>
                   <a:srgbClr val="141C2E"/>
                 </a:solidFill>
@@ -3990,11 +3990,11 @@
           <a:p>
             <a:pPr algn="ctr">
               <a:spcAft>
-                <a:spcPts val="562"/>
-              </a:spcAft>
-            </a:pPr>
-            <a:r>
-              <a:rPr sz="1250" b="0">
+                <a:spcPts val="630"/>
+              </a:spcAft>
+            </a:pPr>
+            <a:r>
+              <a:rPr sz="1400" b="0">
                 <a:solidFill>
                   <a:srgbClr val="5B6477"/>
                 </a:solidFill>
@@ -4074,11 +4074,11 @@
           <a:p>
             <a:pPr algn="ctr">
               <a:spcAft>
-                <a:spcPts val="1530"/>
-              </a:spcAft>
-            </a:pPr>
-            <a:r>
-              <a:rPr sz="3400" b="1">
+                <a:spcPts val="1170"/>
+              </a:spcAft>
+            </a:pPr>
+            <a:r>
+              <a:rPr sz="2600" b="1">
                 <a:solidFill>
                   <a:srgbClr val="141C2E"/>
                 </a:solidFill>
@@ -4113,11 +4113,11 @@
           <a:p>
             <a:pPr algn="ctr">
               <a:spcAft>
-                <a:spcPts val="562"/>
-              </a:spcAft>
-            </a:pPr>
-            <a:r>
-              <a:rPr sz="1250" b="0">
+                <a:spcPts val="630"/>
+              </a:spcAft>
+            </a:pPr>
+            <a:r>
+              <a:rPr sz="1400" b="0">
                 <a:solidFill>
                   <a:srgbClr val="5B6477"/>
                 </a:solidFill>
@@ -4197,11 +4197,11 @@
           <a:p>
             <a:pPr algn="ctr">
               <a:spcAft>
-                <a:spcPts val="1530"/>
-              </a:spcAft>
-            </a:pPr>
-            <a:r>
-              <a:rPr sz="3400" b="1">
+                <a:spcPts val="1170"/>
+              </a:spcAft>
+            </a:pPr>
+            <a:r>
+              <a:rPr sz="2600" b="1">
                 <a:solidFill>
                   <a:srgbClr val="141C2E"/>
                 </a:solidFill>
@@ -4236,11 +4236,11 @@
           <a:p>
             <a:pPr algn="ctr">
               <a:spcAft>
-                <a:spcPts val="562"/>
-              </a:spcAft>
-            </a:pPr>
-            <a:r>
-              <a:rPr sz="1250" b="0">
+                <a:spcPts val="630"/>
+              </a:spcAft>
+            </a:pPr>
+            <a:r>
+              <a:rPr sz="1400" b="0">
                 <a:solidFill>
                   <a:srgbClr val="5B6477"/>
                 </a:solidFill>
@@ -4743,11 +4743,11 @@
           <a:p>
             <a:pPr algn="ctr">
               <a:spcAft>
-                <a:spcPts val="562"/>
-              </a:spcAft>
-            </a:pPr>
-            <a:r>
-              <a:rPr sz="1250" b="0">
+                <a:spcPts val="630"/>
+              </a:spcAft>
+            </a:pPr>
+            <a:r>
+              <a:rPr sz="1400" b="0">
                 <a:solidFill>
                   <a:srgbClr val="5B6477"/>
                 </a:solidFill>
@@ -4866,11 +4866,11 @@
           <a:p>
             <a:pPr algn="ctr">
               <a:spcAft>
-                <a:spcPts val="562"/>
-              </a:spcAft>
-            </a:pPr>
-            <a:r>
-              <a:rPr sz="1250" b="0">
+                <a:spcPts val="630"/>
+              </a:spcAft>
+            </a:pPr>
+            <a:r>
+              <a:rPr sz="1400" b="0">
                 <a:solidFill>
                   <a:srgbClr val="5B6477"/>
                 </a:solidFill>
@@ -4989,11 +4989,11 @@
           <a:p>
             <a:pPr algn="ctr">
               <a:spcAft>
-                <a:spcPts val="562"/>
-              </a:spcAft>
-            </a:pPr>
-            <a:r>
-              <a:rPr sz="1250" b="0">
+                <a:spcPts val="630"/>
+              </a:spcAft>
+            </a:pPr>
+            <a:r>
+              <a:rPr sz="1400" b="0">
                 <a:solidFill>
                   <a:srgbClr val="5B6477"/>
                 </a:solidFill>
@@ -5718,8 +5718,8 @@
         </p:blipFill>
         <p:spPr>
           <a:xfrm>
-            <a:off x="822960" y="1828800"/>
-            <a:ext cx="10515600" cy="5321227"/>
+            <a:off x="1463040" y="1783080"/>
+            <a:ext cx="9235440" cy="4673425"/>
           </a:xfrm>
           <a:prstGeom prst="rect">
             <a:avLst/>
@@ -5929,7 +5929,7 @@
         <p:spPr>
           <a:xfrm>
             <a:off x="548640" y="1828800"/>
-            <a:ext cx="7589520" cy="4743450"/>
+            <a:ext cx="7680960" cy="4293220"/>
           </a:xfrm>
           <a:prstGeom prst="rect">
             <a:avLst/>
@@ -6384,8 +6384,8 @@
         </p:blipFill>
         <p:spPr>
           <a:xfrm>
-            <a:off x="6583680" y="1920240"/>
-            <a:ext cx="5120640" cy="3200400"/>
+            <a:off x="6492240" y="1828800"/>
+            <a:ext cx="5303520" cy="3449444"/>
           </a:xfrm>
           <a:prstGeom prst="rect">
             <a:avLst/>
@@ -6717,8 +6717,8 @@
         </p:blipFill>
         <p:spPr>
           <a:xfrm>
-            <a:off x="6766560" y="1920240"/>
-            <a:ext cx="4937760" cy="3086100"/>
+            <a:off x="6583680" y="1828800"/>
+            <a:ext cx="5212080" cy="3178098"/>
           </a:xfrm>
           <a:prstGeom prst="rect">
             <a:avLst/>
@@ -7058,13 +7058,13 @@
           <a:p>
             <a:pPr algn="ctr">
               <a:spcAft>
-                <a:spcPts val="562"/>
-              </a:spcAft>
-            </a:pPr>
-            <a:r>
-              <a:rPr sz="1250" b="0">
-                <a:solidFill>
-                  <a:srgbClr val="5B6477"/>
+                <a:spcPts val="630"/>
+              </a:spcAft>
+            </a:pPr>
+            <a:r>
+              <a:rPr sz="1400" b="0">
+                <a:solidFill>
+                  <a:srgbClr val="F2F5FA"/>
                 </a:solidFill>
                 <a:latin typeface="Segoe UI"/>
               </a:rPr>
@@ -7182,13 +7182,13 @@
           <a:p>
             <a:pPr algn="ctr">
               <a:spcAft>
-                <a:spcPts val="562"/>
-              </a:spcAft>
-            </a:pPr>
-            <a:r>
-              <a:rPr sz="1250" b="0">
-                <a:solidFill>
-                  <a:srgbClr val="5B6477"/>
+                <a:spcPts val="630"/>
+              </a:spcAft>
+            </a:pPr>
+            <a:r>
+              <a:rPr sz="1400" b="0">
+                <a:solidFill>
+                  <a:srgbClr val="F2F5FA"/>
                 </a:solidFill>
                 <a:latin typeface="Segoe UI"/>
               </a:rPr>
@@ -7306,13 +7306,13 @@
           <a:p>
             <a:pPr algn="ctr">
               <a:spcAft>
-                <a:spcPts val="562"/>
-              </a:spcAft>
-            </a:pPr>
-            <a:r>
-              <a:rPr sz="1250" b="0">
-                <a:solidFill>
-                  <a:srgbClr val="5B6477"/>
+                <a:spcPts val="630"/>
+              </a:spcAft>
+            </a:pPr>
+            <a:r>
+              <a:rPr sz="1400" b="0">
+                <a:solidFill>
+                  <a:srgbClr val="F2F5FA"/>
                 </a:solidFill>
                 <a:latin typeface="Segoe UI"/>
               </a:rPr>
@@ -7401,7 +7401,7 @@
                 </a:solidFill>
                 <a:latin typeface="Segoe UI"/>
               </a:rPr>
-              <a:t>0.03%</a:t>
+              <a:t>0,03%</a:t>
             </a:r>
           </a:p>
         </p:txBody>
@@ -7430,13 +7430,13 @@
           <a:p>
             <a:pPr algn="ctr">
               <a:spcAft>
-                <a:spcPts val="562"/>
-              </a:spcAft>
-            </a:pPr>
-            <a:r>
-              <a:rPr sz="1250" b="0">
-                <a:solidFill>
-                  <a:srgbClr val="5B6477"/>
+                <a:spcPts val="630"/>
+              </a:spcAft>
+            </a:pPr>
+            <a:r>
+              <a:rPr sz="1400" b="0">
+                <a:solidFill>
+                  <a:srgbClr val="F2F5FA"/>
                 </a:solidFill>
                 <a:latin typeface="Segoe UI"/>
               </a:rPr>
@@ -7554,13 +7554,13 @@
           <a:p>
             <a:pPr algn="ctr">
               <a:spcAft>
-                <a:spcPts val="562"/>
-              </a:spcAft>
-            </a:pPr>
-            <a:r>
-              <a:rPr sz="1250" b="0">
-                <a:solidFill>
-                  <a:srgbClr val="5B6477"/>
+                <a:spcPts val="630"/>
+              </a:spcAft>
+            </a:pPr>
+            <a:r>
+              <a:rPr sz="1400" b="0">
+                <a:solidFill>
+                  <a:srgbClr val="F2F5FA"/>
                 </a:solidFill>
                 <a:latin typeface="Segoe UI"/>
               </a:rPr>
@@ -7604,7 +7604,7 @@
                 </a:solidFill>
                 <a:latin typeface="Segoe UI"/>
               </a:rPr>
-              <a:t>Publicamos o holdout de propósito: as regras foram escritas sobre as seguradoras que lemos; o LLM é o que generaliza.</a:t>
+              <a:t>Publicamos o holdout de propósito: as regras foram escritas sobre as seguradoras que lemos. Em documento novo, o LLM acrescenta acerto — e o Verificador segura o que ele erra.</a:t>
             </a:r>
           </a:p>
         </p:txBody>

</xml_diff>

<commit_message>
Interface: identidade visual, guia de 3 passos, textos sem jargão, quadro comparativo em HTML escapado
- Ficha abre na cotação (onde há números) e explica o que é condição geral
- Resumo do Relator troca códigos internos (mais_favoravel) por palavras
- Telas, relatório técnico e pitch regenerados com a nova interface

Co-Authored-By: Claude Opus 5 <noreply@anthropic.com>
</commit_message>
<xml_diff>
--- a/Projeto_Final_Artefatos/InsurMinds_Projeto_Final.pptx
+++ b/Projeto_Final_Artefatos/InsurMinds_Projeto_Final.pptx
@@ -5929,7 +5929,7 @@
         <p:spPr>
           <a:xfrm>
             <a:off x="548640" y="1828800"/>
-            <a:ext cx="7680960" cy="4293220"/>
+            <a:ext cx="7680960" cy="4449337"/>
           </a:xfrm>
           <a:prstGeom prst="rect">
             <a:avLst/>
@@ -6370,7 +6370,7 @@
       </p:sp>
       <p:pic>
         <p:nvPicPr>
-          <p:cNvPr id="7" name="Picture 6" descr="03_ficha_coberturas.png"/>
+          <p:cNvPr id="7" name="Picture 6" descr="03_ficha_evidencia.png"/>
           <p:cNvPicPr>
             <a:picLocks noChangeAspect="1"/>
           </p:cNvPicPr>
@@ -6385,7 +6385,7 @@
         <p:spPr>
           <a:xfrm>
             <a:off x="6492240" y="1828800"/>
-            <a:ext cx="5303520" cy="3449444"/>
+            <a:ext cx="5303520" cy="2533185"/>
           </a:xfrm>
           <a:prstGeom prst="rect">
             <a:avLst/>
@@ -6718,7 +6718,7 @@
         <p:spPr>
           <a:xfrm>
             <a:off x="6583680" y="1828800"/>
-            <a:ext cx="5212080" cy="3178098"/>
+            <a:ext cx="5212080" cy="3310518"/>
           </a:xfrm>
           <a:prstGeom prst="rect">
             <a:avLst/>

</xml_diff>

<commit_message>
Memória de ensinamentos: o corretor ensina, o Verificador confere
- prisma/ensino.py: ensinar (trecho existe, número, sem instrução a IA), reaplicar em
  outra redação igual (>= 0,90, sem palavra de exceção nova), exemplos para a IA
- Armazém: tabela ensinamentos; grafo reaplica após a fusão; extrator usa exemplos
- Interface: botão Ensinar/corrigir na Ficha, lista do que foi aprendido, painel na Qualidade
- Experimento (só documentos de desenvolvimento): 3 ensinamentos corrigiram 6 campos,
  3 transferidos (1 no holdout), 0 valor errado novo (docs/DESVIOS.md D11)
- Capturas estáveis (IA desligada na comparação, espera pelo quadro); corrige telas do
  commit anterior que saíram com a comparação ainda carregando
- Seletor distingue versões da mesma seguradora; dica em inglês oculta

Co-Authored-By: Claude Opus 5 <noreply@anthropic.com>
</commit_message>
<xml_diff>
--- a/Projeto_Final_Artefatos/InsurMinds_Projeto_Final.pptx
+++ b/Projeto_Final_Artefatos/InsurMinds_Projeto_Final.pptx
@@ -3454,7 +3454,7 @@
                 </a:solidFill>
                 <a:latin typeface="Segoe UI"/>
               </a:rPr>
-              <a:t>sem LLM caem em seguradora nova.</a:t>
+              <a:t>sem LLM caem em seguradora nova (o corretor ensina uma vez).</a:t>
             </a:r>
           </a:p>
           <a:p>
@@ -4000,7 +4000,7 @@
                 </a:solidFill>
                 <a:latin typeface="Segoe UI"/>
               </a:rPr>
-              <a:t>comparar propostas e explicar ao cliente onde cada uma é melhor</a:t>
+              <a:t>comparar propostas e explicar ao cliente onde cada uma é mais favorável</a:t>
             </a:r>
           </a:p>
         </p:txBody>
@@ -6959,7 +6959,7 @@
         <p:spPr>
           <a:xfrm>
             <a:off x="548640" y="2194560"/>
-            <a:ext cx="2075688" cy="2377440"/>
+            <a:ext cx="2628900" cy="2377440"/>
           </a:xfrm>
           <a:prstGeom prst="roundRect">
             <a:avLst>
@@ -7004,7 +7004,7 @@
         <p:spPr>
           <a:xfrm>
             <a:off x="548640" y="2359152"/>
-            <a:ext cx="2075688" cy="822960"/>
+            <a:ext cx="2628900" cy="822960"/>
           </a:xfrm>
           <a:prstGeom prst="rect">
             <a:avLst/>
@@ -7043,7 +7043,7 @@
         <p:spPr>
           <a:xfrm>
             <a:off x="685800" y="3154680"/>
-            <a:ext cx="1801368" cy="1371600"/>
+            <a:ext cx="2354580" cy="1371600"/>
           </a:xfrm>
           <a:prstGeom prst="rect">
             <a:avLst/>
@@ -7082,8 +7082,8 @@
         </p:nvSpPr>
         <p:spPr>
           <a:xfrm>
-            <a:off x="2761488" y="2194560"/>
-            <a:ext cx="2075688" cy="2377440"/>
+            <a:off x="3314700" y="2194560"/>
+            <a:ext cx="2628900" cy="2377440"/>
           </a:xfrm>
           <a:prstGeom prst="roundRect">
             <a:avLst>
@@ -7127,8 +7127,8 @@
         </p:nvSpPr>
         <p:spPr>
           <a:xfrm>
-            <a:off x="2761488" y="2359152"/>
-            <a:ext cx="2075688" cy="822960"/>
+            <a:off x="3314700" y="2359152"/>
+            <a:ext cx="2628900" cy="822960"/>
           </a:xfrm>
           <a:prstGeom prst="rect">
             <a:avLst/>
@@ -7166,8 +7166,8 @@
         </p:nvSpPr>
         <p:spPr>
           <a:xfrm>
-            <a:off x="2898648" y="3154680"/>
-            <a:ext cx="1801368" cy="1371600"/>
+            <a:off x="3451860" y="3154680"/>
+            <a:ext cx="2354580" cy="1371600"/>
           </a:xfrm>
           <a:prstGeom prst="rect">
             <a:avLst/>
@@ -7206,8 +7206,8 @@
         </p:nvSpPr>
         <p:spPr>
           <a:xfrm>
-            <a:off x="4974336" y="2194560"/>
-            <a:ext cx="2075688" cy="2377440"/>
+            <a:off x="6080760" y="2194560"/>
+            <a:ext cx="2628900" cy="2377440"/>
           </a:xfrm>
           <a:prstGeom prst="roundRect">
             <a:avLst>
@@ -7251,8 +7251,8 @@
         </p:nvSpPr>
         <p:spPr>
           <a:xfrm>
-            <a:off x="4974336" y="2359152"/>
-            <a:ext cx="2075688" cy="822960"/>
+            <a:off x="6080760" y="2359152"/>
+            <a:ext cx="2628900" cy="822960"/>
           </a:xfrm>
           <a:prstGeom prst="rect">
             <a:avLst/>
@@ -7290,8 +7290,8 @@
         </p:nvSpPr>
         <p:spPr>
           <a:xfrm>
-            <a:off x="5111496" y="3154680"/>
-            <a:ext cx="1801368" cy="1371600"/>
+            <a:off x="6217920" y="3154680"/>
+            <a:ext cx="2354580" cy="1371600"/>
           </a:xfrm>
           <a:prstGeom prst="rect">
             <a:avLst/>
@@ -7330,8 +7330,8 @@
         </p:nvSpPr>
         <p:spPr>
           <a:xfrm>
-            <a:off x="7187184" y="2194560"/>
-            <a:ext cx="2075688" cy="2377440"/>
+            <a:off x="8846820" y="2194560"/>
+            <a:ext cx="2628900" cy="2377440"/>
           </a:xfrm>
           <a:prstGeom prst="roundRect">
             <a:avLst>
@@ -7375,8 +7375,8 @@
         </p:nvSpPr>
         <p:spPr>
           <a:xfrm>
-            <a:off x="7187184" y="2359152"/>
-            <a:ext cx="2075688" cy="822960"/>
+            <a:off x="8846820" y="2359152"/>
+            <a:ext cx="2628900" cy="822960"/>
           </a:xfrm>
           <a:prstGeom prst="rect">
             <a:avLst/>
@@ -7401,7 +7401,7 @@
                 </a:solidFill>
                 <a:latin typeface="Segoe UI"/>
               </a:rPr>
-              <a:t>0,03%</a:t>
+              <a:t>15/15</a:t>
             </a:r>
           </a:p>
         </p:txBody>
@@ -7414,8 +7414,8 @@
         </p:nvSpPr>
         <p:spPr>
           <a:xfrm>
-            <a:off x="7324344" y="3154680"/>
-            <a:ext cx="1801368" cy="1371600"/>
+            <a:off x="8983980" y="3154680"/>
+            <a:ext cx="2354580" cy="1371600"/>
           </a:xfrm>
           <a:prstGeom prst="rect">
             <a:avLst/>
@@ -7440,130 +7440,6 @@
                 </a:solidFill>
                 <a:latin typeface="Segoe UI"/>
               </a:rPr>
-              <a:t>erro de caractere do OCR
-(por linha)</a:t>
-            </a:r>
-          </a:p>
-        </p:txBody>
-      </p:sp>
-      <p:sp>
-        <p:nvSpPr>
-          <p:cNvPr id="18" name="Rounded Rectangle 17"/>
-          <p:cNvSpPr/>
-          <p:nvPr/>
-        </p:nvSpPr>
-        <p:spPr>
-          <a:xfrm>
-            <a:off x="9400032" y="2194560"/>
-            <a:ext cx="2075688" cy="2377440"/>
-          </a:xfrm>
-          <a:prstGeom prst="roundRect">
-            <a:avLst>
-              <a:gd name="adj" fmla="val 8000"/>
-            </a:avLst>
-          </a:prstGeom>
-          <a:solidFill>
-            <a:srgbClr val="222D45"/>
-          </a:solidFill>
-          <a:ln>
-            <a:noFill/>
-          </a:ln>
-        </p:spPr>
-        <p:style>
-          <a:lnRef idx="1">
-            <a:schemeClr val="accent1"/>
-          </a:lnRef>
-          <a:fillRef idx="3">
-            <a:schemeClr val="accent1"/>
-          </a:fillRef>
-          <a:effectRef idx="2">
-            <a:schemeClr val="accent1"/>
-          </a:effectRef>
-          <a:fontRef idx="minor">
-            <a:schemeClr val="lt1"/>
-          </a:fontRef>
-        </p:style>
-        <p:txBody>
-          <a:bodyPr rtlCol="0" anchor="ctr"/>
-          <a:lstStyle/>
-          <a:p>
-            <a:pPr algn="ctr"/>
-          </a:p>
-        </p:txBody>
-      </p:sp>
-      <p:sp>
-        <p:nvSpPr>
-          <p:cNvPr id="19" name="TextBox 18"/>
-          <p:cNvSpPr txBox="1"/>
-          <p:nvPr/>
-        </p:nvSpPr>
-        <p:spPr>
-          <a:xfrm>
-            <a:off x="9400032" y="2359152"/>
-            <a:ext cx="2075688" cy="822960"/>
-          </a:xfrm>
-          <a:prstGeom prst="rect">
-            <a:avLst/>
-          </a:prstGeom>
-          <a:noFill/>
-        </p:spPr>
-        <p:txBody>
-          <a:bodyPr wrap="square" anchor="t">
-            <a:spAutoFit/>
-          </a:bodyPr>
-          <a:lstStyle/>
-          <a:p>
-            <a:pPr algn="ctr">
-              <a:spcAft>
-                <a:spcPts val="1530"/>
-              </a:spcAft>
-            </a:pPr>
-            <a:r>
-              <a:rPr sz="3400" b="1">
-                <a:solidFill>
-                  <a:srgbClr val="D8B877"/>
-                </a:solidFill>
-                <a:latin typeface="Segoe UI"/>
-              </a:rPr>
-              <a:t>15/15</a:t>
-            </a:r>
-          </a:p>
-        </p:txBody>
-      </p:sp>
-      <p:sp>
-        <p:nvSpPr>
-          <p:cNvPr id="20" name="TextBox 19"/>
-          <p:cNvSpPr txBox="1"/>
-          <p:nvPr/>
-        </p:nvSpPr>
-        <p:spPr>
-          <a:xfrm>
-            <a:off x="9537192" y="3154680"/>
-            <a:ext cx="1801368" cy="1371600"/>
-          </a:xfrm>
-          <a:prstGeom prst="rect">
-            <a:avLst/>
-          </a:prstGeom>
-          <a:noFill/>
-        </p:spPr>
-        <p:txBody>
-          <a:bodyPr wrap="square" anchor="t">
-            <a:spAutoFit/>
-          </a:bodyPr>
-          <a:lstStyle/>
-          <a:p>
-            <a:pPr algn="ctr">
-              <a:spcAft>
-                <a:spcPts val="630"/>
-              </a:spcAft>
-            </a:pPr>
-            <a:r>
-              <a:rPr sz="1400" b="0">
-                <a:solidFill>
-                  <a:srgbClr val="F2F5FA"/>
-                </a:solidFill>
-                <a:latin typeface="Segoe UI"/>
-              </a:rPr>
               <a:t>injeções de prompt barradas
 0 falso positivo</a:t>
             </a:r>
@@ -7572,7 +7448,7 @@
       </p:sp>
       <p:sp>
         <p:nvSpPr>
-          <p:cNvPr id="21" name="TextBox 20"/>
+          <p:cNvPr id="18" name="TextBox 17"/>
           <p:cNvSpPr txBox="1"/>
           <p:nvPr/>
         </p:nvSpPr>
@@ -7803,7 +7679,7 @@
         </p:nvSpPr>
         <p:spPr>
           <a:xfrm>
-            <a:off x="548640" y="2011680"/>
+            <a:off x="548640" y="1920240"/>
             <a:ext cx="10972800" cy="4572000"/>
           </a:xfrm>
           <a:prstGeom prst="rect">
@@ -7819,11 +7695,11 @@
           <a:p>
             <a:pPr>
               <a:spcAft>
-                <a:spcPts val="1260"/>
-              </a:spcAft>
-            </a:pPr>
-            <a:r>
-              <a:rPr b="1" sz="1800">
+                <a:spcPts val="1189"/>
+              </a:spcAft>
+            </a:pPr>
+            <a:r>
+              <a:rPr b="1" sz="1700">
                 <a:solidFill>
                   <a:srgbClr val="141C2E"/>
                 </a:solidFill>
@@ -7832,7 +7708,7 @@
               <a:t>Regras em YAML, </a:t>
             </a:r>
             <a:r>
-              <a:rPr sz="1800">
+              <a:rPr sz="1700">
                 <a:solidFill>
                   <a:srgbClr val="5B6477"/>
                 </a:solidFill>
@@ -7844,11 +7720,11 @@
           <a:p>
             <a:pPr>
               <a:spcAft>
-                <a:spcPts val="1260"/>
-              </a:spcAft>
-            </a:pPr>
-            <a:r>
-              <a:rPr b="1" sz="1800">
+                <a:spcPts val="1189"/>
+              </a:spcAft>
+            </a:pPr>
+            <a:r>
+              <a:rPr b="1" sz="1700">
                 <a:solidFill>
                   <a:srgbClr val="141C2E"/>
                 </a:solidFill>
@@ -7857,7 +7733,7 @@
               <a:t>Roda sem chave: </a:t>
             </a:r>
             <a:r>
-              <a:rPr sz="1800">
+              <a:rPr sz="1700">
                 <a:solidFill>
                   <a:srgbClr val="5B6477"/>
                 </a:solidFill>
@@ -7869,11 +7745,11 @@
           <a:p>
             <a:pPr>
               <a:spcAft>
-                <a:spcPts val="1260"/>
-              </a:spcAft>
-            </a:pPr>
-            <a:r>
-              <a:rPr b="1" sz="1800">
+                <a:spcPts val="1189"/>
+              </a:spcAft>
+            </a:pPr>
+            <a:r>
+              <a:rPr b="1" sz="1700">
                 <a:solidFill>
                   <a:srgbClr val="141C2E"/>
                 </a:solidFill>
@@ -7882,7 +7758,7 @@
               <a:t>Custo zero: </a:t>
             </a:r>
             <a:r>
-              <a:rPr sz="1800">
+              <a:rPr sz="1700">
                 <a:solidFill>
                   <a:srgbClr val="5B6477"/>
                 </a:solidFill>
@@ -7894,36 +7770,36 @@
           <a:p>
             <a:pPr>
               <a:spcAft>
-                <a:spcPts val="1260"/>
-              </a:spcAft>
-            </a:pPr>
-            <a:r>
-              <a:rPr b="1" sz="1800">
+                <a:spcPts val="1189"/>
+              </a:spcAft>
+            </a:pPr>
+            <a:r>
+              <a:rPr b="1" sz="1700">
                 <a:solidFill>
                   <a:srgbClr val="141C2E"/>
                 </a:solidFill>
                 <a:latin typeface="Segoe UI"/>
               </a:rPr>
-              <a:t>OCR por página: </a:t>
-            </a:r>
-            <a:r>
-              <a:rPr sz="1800">
+              <a:t>Aprende com o corretor: </a:t>
+            </a:r>
+            <a:r>
+              <a:rPr sz="1700">
                 <a:solidFill>
                   <a:srgbClr val="5B6477"/>
                 </a:solidFill>
                 <a:latin typeface="Segoe UI"/>
               </a:rPr>
-              <a:t>apólice real mistura páginas escaneadas e digitais.</a:t>
+              <a:t>3 ensinamentos corrigiram 6 campos, 3 em outros documentos, 0 erro novo.</a:t>
             </a:r>
           </a:p>
           <a:p>
             <a:pPr>
               <a:spcAft>
-                <a:spcPts val="1260"/>
-              </a:spcAft>
-            </a:pPr>
-            <a:r>
-              <a:rPr b="1" sz="1800">
+                <a:spcPts val="1189"/>
+              </a:spcAft>
+            </a:pPr>
+            <a:r>
+              <a:rPr b="1" sz="1700">
                 <a:solidFill>
                   <a:srgbClr val="141C2E"/>
                 </a:solidFill>
@@ -7932,7 +7808,7 @@
               <a:t>Rastro completo: </a:t>
             </a:r>
             <a:r>
-              <a:rPr sz="1800">
+              <a:rPr sz="1700">
                 <a:solidFill>
                   <a:srgbClr val="5B6477"/>
                 </a:solidFill>
@@ -7943,6 +7819,30 @@
           </a:p>
         </p:txBody>
       </p:sp>
+      <p:pic>
+        <p:nvPicPr>
+          <p:cNvPr id="7" name="Picture 6" descr="10_ensinar.png"/>
+          <p:cNvPicPr>
+            <a:picLocks noChangeAspect="1"/>
+          </p:cNvPicPr>
+          <p:nvPr/>
+        </p:nvPicPr>
+        <p:blipFill>
+          <a:blip r:embed="rId2"/>
+          <a:stretch>
+            <a:fillRect/>
+          </a:stretch>
+        </p:blipFill>
+        <p:spPr>
+          <a:xfrm>
+            <a:off x="7589520" y="4343400"/>
+            <a:ext cx="4023360" cy="2054482"/>
+          </a:xfrm>
+          <a:prstGeom prst="rect">
+            <a:avLst/>
+          </a:prstGeom>
+        </p:spPr>
+      </p:pic>
     </p:spTree>
   </p:cSld>
   <p:clrMapOvr>

</xml_diff>